<commit_message>
replace anthropic with ollama
</commit_message>
<xml_diff>
--- a/web-detective-workshop.pptx
+++ b/web-detective-workshop.pptx
@@ -3473,7 +3473,7 @@
                   <a:srgbClr val="8B949E"/>
                 </a:solidFill>
               </a:rPr>
-              <a:t>Playwright  ·  Anthropic SDK  ·  MCP  ·  GitHub Actions  ·  8 hours  ·  Senior QA / SDET</a:t>
+              <a:t>Playwright  ·  Ollama + DeepSeek-R1  ·  MCP  ·  GitHub Actions  ·  8 hours  ·  Senior QA / SDET</a:t>
             </a:r>
           </a:p>
         </p:txBody>
@@ -24350,7 +24350,7 @@
                 </a:solidFill>
                 <a:latin typeface="Courier New"/>
               </a:rPr>
-              <a:t>ANTHROPIC_API_KEY</a:t>
+              <a:t>Ollama + DeepSeek-R1</a:t>
             </a:r>
           </a:p>
         </p:txBody>
@@ -24427,7 +24427,7 @@
                   <a:srgbClr val="FFFFFF"/>
                 </a:solidFill>
               </a:rPr>
-              <a:t>Anthropic SDK authentication</a:t>
+              <a:t>Local LLM (no API key)</a:t>
             </a:r>
           </a:p>
         </p:txBody>
@@ -24504,7 +24504,7 @@
                   <a:srgbClr val="FFFFFF"/>
                 </a:solidFill>
               </a:rPr>
-              <a:t>echo $ANTHROPIC_API_KEY</a:t>
+              <a:t>ollama pull deepseek-r1:8b</a:t>
             </a:r>
           </a:p>
         </p:txBody>
@@ -32040,7 +32040,7 @@
                   <a:srgbClr val="FFFFFF"/>
                 </a:solidFill>
               </a:rPr>
-              <a:t>Anthropic SDK (LLM reasoning)</a:t>
+              <a:t>Ollama + DeepSeek-R1 (local LLM reasoning)</a:t>
             </a:r>
           </a:p>
           <a:p>
@@ -33231,7 +33231,7 @@
                   <a:srgbClr val="8B949E"/>
                 </a:solidFill>
               </a:rPr>
-              <a:t>ANTHROPIC_API_KEY=sk-... npx ts-node examples/ch4.1-playwright-agents/planner.ts
+              <a:t>npx ts-node examples/ch4.1-playwright-agents/planner.ts
 Review specs/web-detective.md — does it cover login, dashboard, and products?</a:t>
             </a:r>
           </a:p>
@@ -33988,7 +33988,7 @@
                   <a:srgbClr val="8B949E"/>
                 </a:solidFill>
               </a:rPr>
-              <a:t>45 min  ·  Observe → Plan → Act → Verify → Learn with Anthropic SDK</a:t>
+              <a:t>45 min  ·  Observe → Plan → Act → Verify → Learn with Ollama + DeepSeek-R1</a:t>
             </a:r>
           </a:p>
         </p:txBody>
@@ -34271,7 +34271,7 @@
                   <a:srgbClr val="FFFFFF"/>
                 </a:solidFill>
               </a:rPr>
-              <a:t>agent.ts     The reasoning loop: calls Claude, executes tools, collects results</a:t>
+              <a:t>agent.ts     The reasoning loop: calls the local model, executes tools, collects results</a:t>
             </a:r>
           </a:p>
           <a:p>
@@ -34286,7 +34286,7 @@
                   <a:srgbClr val="FFFFFF"/>
                 </a:solidFill>
               </a:rPr>
-              <a:t>tools.ts     The tool registry: typed JSON schemas Claude uses to call Playwright</a:t>
+              <a:t>tools.ts     The tool registry: the JSON actions the model emits to call Playwright</a:t>
             </a:r>
           </a:p>
           <a:p>
@@ -34346,7 +34346,7 @@
                   <a:srgbClr val="FFFFFF"/>
                 </a:solidFill>
               </a:rPr>
-              <a:t>  1. Send goal + conversation history to Claude</a:t>
+              <a:t>  1. Send goal + conversation history to DeepSeek-R1 via Ollama</a:t>
             </a:r>
           </a:p>
           <a:p>
@@ -34361,7 +34361,7 @@
                   <a:srgbClr val="FFFFFF"/>
                 </a:solidFill>
               </a:rPr>
-              <a:t>  2. Claude responds with tool_use blocks</a:t>
+              <a:t>  2. Model returns ONE JSON action { tool, input }</a:t>
             </a:r>
           </a:p>
           <a:p>
@@ -34376,7 +34376,7 @@
                   <a:srgbClr val="FFFFFF"/>
                 </a:solidFill>
               </a:rPr>
-              <a:t>  3. Execute each tool against the live browser</a:t>
+              <a:t>  3. Execute that tool against the live browser</a:t>
             </a:r>
           </a:p>
           <a:p>
@@ -34391,7 +34391,7 @@
                   <a:srgbClr val="FFFFFF"/>
                 </a:solidFill>
               </a:rPr>
-              <a:t>  4. Append tool results to conversation history</a:t>
+              <a:t>  4. Append the tool result to conversation history</a:t>
             </a:r>
           </a:p>
           <a:p>
@@ -34451,7 +34451,7 @@
                   <a:srgbClr val="FFFFFF"/>
                 </a:solidFill>
               </a:rPr>
-              <a:t>  • done() is a tool — not a return — so Claude controls termination</a:t>
+              <a:t>  • done() is a tool — not a return — so the model controls termination</a:t>
             </a:r>
           </a:p>
           <a:p>
@@ -34481,7 +34481,7 @@
                   <a:srgbClr val="FFFFFF"/>
                 </a:solidFill>
               </a:rPr>
-              <a:t>  • System prompt is cached (cache_control: ephemeral) for cost savings</a:t>
+              <a:t>  • No native tool-calling → a prompt-based JSON action protocol drives dispatch</a:t>
             </a:r>
           </a:p>
         </p:txBody>
@@ -34786,7 +34786,7 @@
                 </a:solidFill>
                 <a:latin typeface="Courier New"/>
               </a:rPr>
-              <a:t>  const response = await client.messages.create({</a:t>
+              <a:t>  const reply = await chat({</a:t>
             </a:r>
           </a:p>
           <a:p>
@@ -34802,7 +34802,7 @@
                 </a:solidFill>
                 <a:latin typeface="Courier New"/>
               </a:rPr>
-              <a:t>    model:    'claude-sonnet-4-6',</a:t>
+              <a:t>    model:    process.env.WORKSHOP_MODEL ?? 'deepseek-r1:8b',</a:t>
             </a:r>
           </a:p>
           <a:p>
@@ -34818,7 +34818,7 @@
                 </a:solidFill>
                 <a:latin typeface="Courier New"/>
               </a:rPr>
-              <a:t>    system:   [{ type: 'text', text: SYSTEM_PROMPT,</a:t>
+              <a:t>    system:   SYSTEM_PROMPT,</a:t>
             </a:r>
           </a:p>
           <a:p>
@@ -34830,11 +34830,27 @@
             <a:r>
               <a:rPr sz="1200" b="0">
                 <a:solidFill>
+                  <a:srgbClr val="FFFFFF"/>
+                </a:solidFill>
+                <a:latin typeface="Courier New"/>
+              </a:rPr>
+              <a:t>    messages,</a:t>
+            </a:r>
+          </a:p>
+          <a:p>
+            <a:pPr algn="l">
+              <a:lnSpc>
+                <a:spcPts val="1500"/>
+              </a:lnSpc>
+            </a:pPr>
+            <a:r>
+              <a:rPr sz="1200" b="0">
+                <a:solidFill>
                   <a:srgbClr val="39D353"/>
                 </a:solidFill>
                 <a:latin typeface="Courier New"/>
               </a:rPr>
-              <a:t>               cache_control: { type: 'ephemeral' } }],  // cached ✓</a:t>
+              <a:t>  })  // shared/ollama.ts strips &lt;think&gt;…&lt;/think&gt; for us</a:t>
             </a:r>
           </a:p>
           <a:p>
@@ -34850,7 +34866,7 @@
                 </a:solidFill>
                 <a:latin typeface="Courier New"/>
               </a:rPr>
-              <a:t>    tools:    AGENT_TOOLS,</a:t>
+              <a:t>  messages.push({ role: 'assistant', content: reply })</a:t>
             </a:r>
           </a:p>
           <a:p>
@@ -34866,7 +34882,7 @@
                 </a:solidFill>
                 <a:latin typeface="Courier New"/>
               </a:rPr>
-              <a:t>    messages,</a:t>
+              <a:t/>
             </a:r>
           </a:p>
           <a:p>
@@ -34878,11 +34894,11 @@
             <a:r>
               <a:rPr sz="1200" b="0">
                 <a:solidFill>
-                  <a:srgbClr val="FFFFFF"/>
+                  <a:srgbClr val="8B949E"/>
                 </a:solidFill>
                 <a:latin typeface="Courier New"/>
               </a:rPr>
-              <a:t>  })</a:t>
+              <a:t>  // Model returns ONE JSON action per turn: { tool, input }</a:t>
             </a:r>
           </a:p>
           <a:p>
@@ -34898,7 +34914,7 @@
                 </a:solidFill>
                 <a:latin typeface="Courier New"/>
               </a:rPr>
-              <a:t>  messages.push({ role: 'assistant', content: response.content })</a:t>
+              <a:t>  const { tool, input } = JSON.parse(reply)</a:t>
             </a:r>
           </a:p>
           <a:p>
@@ -34910,10 +34926,42 @@
             <a:r>
               <a:rPr sz="1200" b="0">
                 <a:solidFill>
-                  <a:srgbClr val="FFFFFF"/>
+                  <a:srgbClr val="39D353"/>
                 </a:solidFill>
                 <a:latin typeface="Courier New"/>
               </a:rPr>
+              <a:t>  if (tool === 'done') return parseResult(input)</a:t>
+            </a:r>
+          </a:p>
+          <a:p>
+            <a:pPr algn="l">
+              <a:lnSpc>
+                <a:spcPts val="1500"/>
+              </a:lnSpc>
+            </a:pPr>
+            <a:r>
+              <a:rPr sz="1200" b="0">
+                <a:solidFill>
+                  <a:srgbClr val="FFFFFF"/>
+                </a:solidFill>
+                <a:latin typeface="Courier New"/>
+              </a:rPr>
+              <a:t>  const result = await this.execute(tool, input)</a:t>
+            </a:r>
+          </a:p>
+          <a:p>
+            <a:pPr algn="l">
+              <a:lnSpc>
+                <a:spcPts val="1500"/>
+              </a:lnSpc>
+            </a:pPr>
+            <a:r>
+              <a:rPr sz="1200" b="0">
+                <a:solidFill>
+                  <a:srgbClr val="FFFFFF"/>
+                </a:solidFill>
+                <a:latin typeface="Courier New"/>
+              </a:rPr>
               <a:t/>
             </a:r>
           </a:p>
@@ -34930,7 +34978,7 @@
                 </a:solidFill>
                 <a:latin typeface="Courier New"/>
               </a:rPr>
-              <a:t>  for (const block of response.content) {</a:t>
+              <a:t>  messages.push({ role: 'user',</a:t>
             </a:r>
           </a:p>
           <a:p>
@@ -34946,103 +34994,7 @@
                 </a:solidFill>
                 <a:latin typeface="Courier New"/>
               </a:rPr>
-              <a:t>    if (block.type !== 'tool_use') continue</a:t>
-            </a:r>
-          </a:p>
-          <a:p>
-            <a:pPr algn="l">
-              <a:lnSpc>
-                <a:spcPts val="1500"/>
-              </a:lnSpc>
-            </a:pPr>
-            <a:r>
-              <a:rPr sz="1200" b="0">
-                <a:solidFill>
-                  <a:srgbClr val="39D353"/>
-                </a:solidFill>
-                <a:latin typeface="Courier New"/>
-              </a:rPr>
-              <a:t>    if (block.name === 'done') return parseResult(block.input)</a:t>
-            </a:r>
-          </a:p>
-          <a:p>
-            <a:pPr algn="l">
-              <a:lnSpc>
-                <a:spcPts val="1500"/>
-              </a:lnSpc>
-            </a:pPr>
-            <a:r>
-              <a:rPr sz="1200" b="0">
-                <a:solidFill>
-                  <a:srgbClr val="FFFFFF"/>
-                </a:solidFill>
-                <a:latin typeface="Courier New"/>
-              </a:rPr>
-              <a:t>    const result = await this.execute(block.name, block.input)</a:t>
-            </a:r>
-          </a:p>
-          <a:p>
-            <a:pPr algn="l">
-              <a:lnSpc>
-                <a:spcPts val="1500"/>
-              </a:lnSpc>
-            </a:pPr>
-            <a:r>
-              <a:rPr sz="1200" b="0">
-                <a:solidFill>
-                  <a:srgbClr val="FFFFFF"/>
-                </a:solidFill>
-                <a:latin typeface="Courier New"/>
-              </a:rPr>
-              <a:t>    toolResults.push({ type: 'tool_result',</a:t>
-            </a:r>
-          </a:p>
-          <a:p>
-            <a:pPr algn="l">
-              <a:lnSpc>
-                <a:spcPts val="1500"/>
-              </a:lnSpc>
-            </a:pPr>
-            <a:r>
-              <a:rPr sz="1200" b="0">
-                <a:solidFill>
-                  <a:srgbClr val="FFFFFF"/>
-                </a:solidFill>
-                <a:latin typeface="Courier New"/>
-              </a:rPr>
-              <a:t>      tool_use_id: block.id, content: result })</a:t>
-            </a:r>
-          </a:p>
-          <a:p>
-            <a:pPr algn="l">
-              <a:lnSpc>
-                <a:spcPts val="1500"/>
-              </a:lnSpc>
-            </a:pPr>
-            <a:r>
-              <a:rPr sz="1200" b="0">
-                <a:solidFill>
-                  <a:srgbClr val="FFFFFF"/>
-                </a:solidFill>
-                <a:latin typeface="Courier New"/>
-              </a:rPr>
-              <a:t>  }</a:t>
-            </a:r>
-          </a:p>
-          <a:p>
-            <a:pPr algn="l">
-              <a:lnSpc>
-                <a:spcPts val="1500"/>
-              </a:lnSpc>
-            </a:pPr>
-            <a:r>
-              <a:rPr sz="1200" b="0">
-                <a:solidFill>
-                  <a:srgbClr val="FFFFFF"/>
-                </a:solidFill>
-                <a:latin typeface="Courier New"/>
-              </a:rPr>
-              <a:t>  messages.push({ role: 'user', content: toolResults })</a:t>
+              <a:t>    content: JSON.stringify({ tool, result }) })</a:t>
             </a:r>
           </a:p>
           <a:p>
@@ -35230,7 +35182,7 @@
                   <a:srgbClr val="FFFFFF"/>
                 </a:solidFill>
               </a:rPr>
-              <a:t>Tool Registry — What Claude Can Do</a:t>
+              <a:t>Tool Registry — What the Agent Can Do</a:t>
             </a:r>
           </a:p>
         </p:txBody>
@@ -35974,7 +35926,7 @@
                   <a:srgbClr val="8B949E"/>
                 </a:solidFill>
               </a:rPr>
-              <a:t>  → Hard guard — prevents runaway API spend.</a:t>
+              <a:t>  → Hard guard — prevents runaway local inference / runtime.</a:t>
             </a:r>
           </a:p>
           <a:p>
@@ -36236,7 +36188,7 @@
                   <a:srgbClr val="FFFFFF"/>
                 </a:solidFill>
               </a:rPr>
-              <a:t>Prompt Caching — The Math</a:t>
+              <a:t>The JSON Action Protocol — No Native Tool Calls</a:t>
             </a:r>
           </a:p>
         </p:txBody>
@@ -36317,7 +36269,7 @@
                   <a:srgbClr val="8B949E"/>
                 </a:solidFill>
               </a:rPr>
-              <a:t>System prompt is ~1000 tokens and identical on every turn.</a:t>
+              <a:t>DeepSeek-R1 has no native tool-calling API. We drive it with a prompt contract.</a:t>
             </a:r>
           </a:p>
           <a:p>
@@ -36329,10 +36281,10 @@
             <a:r>
               <a:rPr sz="1400" b="0">
                 <a:solidFill>
-                  <a:srgbClr val="F78466"/>
-                </a:solidFill>
-              </a:rPr>
-              <a:t>Without caching: 1000 tokens × 15 turns × $3/MTok = $0.045 per run</a:t>
+                  <a:srgbClr val="FFFFFF"/>
+                </a:solidFill>
+              </a:rPr>
+              <a:t>Each turn the model must return exactly ONE JSON object — nothing else:</a:t>
             </a:r>
           </a:p>
           <a:p>
@@ -36347,7 +36299,7 @@
                   <a:srgbClr val="39D353"/>
                 </a:solidFill>
               </a:rPr>
-              <a:t>With caching (90% discount on read): $0.045 × 0.1 = $0.0045 per run</a:t>
+              <a:t>  { "tool": "click", "input": { "selector": "...", "description": "..." } }</a:t>
             </a:r>
           </a:p>
           <a:p>
@@ -36362,7 +36314,7 @@
                   <a:srgbClr val="FFFFFF"/>
                 </a:solidFill>
               </a:rPr>
-              <a:t>10× cheaper — meaningful at CI scale.</a:t>
+              <a:t>The loop parses it, dispatches to execute(tool, input), feeds the result back.</a:t>
             </a:r>
           </a:p>
           <a:p>
@@ -36392,7 +36344,7 @@
                   <a:srgbClr val="8B949E"/>
                 </a:solidFill>
               </a:rPr>
-              <a:t>How to enable:</a:t>
+              <a:t>Why it works:</a:t>
             </a:r>
           </a:p>
           <a:p>
@@ -36407,7 +36359,7 @@
                   <a:srgbClr val="FFFFFF"/>
                 </a:solidFill>
               </a:rPr>
-              <a:t>  system: [{ type: 'text', text: SYSTEM_PROMPT,</a:t>
+              <a:t>  • The system prompt lists every tool + its input schema as the contract.</a:t>
             </a:r>
           </a:p>
           <a:p>
@@ -36419,10 +36371,70 @@
             <a:r>
               <a:rPr sz="1400" b="0">
                 <a:solidFill>
+                  <a:srgbClr val="FFFFFF"/>
+                </a:solidFill>
+              </a:rPr>
+              <a:t>  • The model reasons in &lt;think&gt;…&lt;/think&gt;; shared/ollama.ts strips it before parse.</a:t>
+            </a:r>
+          </a:p>
+          <a:p>
+            <a:pPr algn="l">
+              <a:lnSpc>
+                <a:spcPts val="1800"/>
+              </a:lnSpc>
+            </a:pPr>
+            <a:r>
+              <a:rPr sz="1400" b="0">
+                <a:solidFill>
+                  <a:srgbClr val="FFFFFF"/>
+                </a:solidFill>
+              </a:rPr>
+              <a:t>  • One action per turn keeps parsing deterministic and the loop auditable.</a:t>
+            </a:r>
+          </a:p>
+          <a:p>
+            <a:pPr algn="l">
+              <a:lnSpc>
+                <a:spcPts val="1800"/>
+              </a:lnSpc>
+            </a:pPr>
+            <a:r>
+              <a:rPr sz="1400" b="0">
+                <a:solidFill>
+                  <a:srgbClr val="FFFFFF"/>
+                </a:solidFill>
+              </a:rPr>
+              <a:t/>
+            </a:r>
+          </a:p>
+          <a:p>
+            <a:pPr algn="l">
+              <a:lnSpc>
+                <a:spcPts val="1800"/>
+              </a:lnSpc>
+            </a:pPr>
+            <a:r>
+              <a:rPr sz="1400" b="0">
+                <a:solidFill>
+                  <a:srgbClr val="8B949E"/>
+                </a:solidFill>
+              </a:rPr>
+              <a:t>Local warm-up, not billing:</a:t>
+            </a:r>
+          </a:p>
+          <a:p>
+            <a:pPr algn="l">
+              <a:lnSpc>
+                <a:spcPts val="1800"/>
+              </a:lnSpc>
+            </a:pPr>
+            <a:r>
+              <a:rPr sz="1400" b="0">
+                <a:solidFill>
                   <a:srgbClr val="39D353"/>
                 </a:solidFill>
               </a:rPr>
-              <a:t>            cache_control: { type: 'ephemeral' } }]</a:t>
+              <a:t>  • Runs on your machine via Ollama — no API key, no per-token cost.</a:t>
             </a:r>
           </a:p>
           <a:p>
@@ -36437,7 +36449,7 @@
                   <a:srgbClr val="FFFFFF"/>
                 </a:solidFill>
               </a:rPr>
-              <a:t/>
+              <a:t>  • Turn 1 is slow while the model loads into memory; later turns are faster.</a:t>
             </a:r>
           </a:p>
           <a:p>
@@ -36449,100 +36461,10 @@
             <a:r>
               <a:rPr sz="1400" b="0">
                 <a:solidFill>
-                  <a:srgbClr val="8B949E"/>
-                </a:solidFill>
-              </a:rPr>
-              <a:t>Rules:</a:t>
-            </a:r>
-          </a:p>
-          <a:p>
-            <a:pPr algn="l">
-              <a:lnSpc>
-                <a:spcPts val="1800"/>
-              </a:lnSpc>
-            </a:pPr>
-            <a:r>
-              <a:rPr sz="1400" b="0">
-                <a:solidFill>
-                  <a:srgbClr val="FFFFFF"/>
-                </a:solidFill>
-              </a:rPr>
-              <a:t>  • Cache TTL = 5 minutes. Reuse within the same agent run is automatic.</a:t>
-            </a:r>
-          </a:p>
-          <a:p>
-            <a:pPr algn="l">
-              <a:lnSpc>
-                <a:spcPts val="1800"/>
-              </a:lnSpc>
-            </a:pPr>
-            <a:r>
-              <a:rPr sz="1400" b="0">
-                <a:solidFill>
-                  <a:srgbClr val="FFFFFF"/>
-                </a:solidFill>
-              </a:rPr>
-              <a:t>  • Only the system prompt benefits here — task prompts vary per run.</a:t>
-            </a:r>
-          </a:p>
-          <a:p>
-            <a:pPr algn="l">
-              <a:lnSpc>
-                <a:spcPts val="1800"/>
-              </a:lnSpc>
-            </a:pPr>
-            <a:r>
-              <a:rPr sz="1400" b="0">
-                <a:solidFill>
-                  <a:srgbClr val="FFFFFF"/>
-                </a:solidFill>
-              </a:rPr>
-              <a:t>  • Check response.usage.cache_read_input_tokens to confirm cache hits.</a:t>
-            </a:r>
-          </a:p>
-          <a:p>
-            <a:pPr algn="l">
-              <a:lnSpc>
-                <a:spcPts val="1800"/>
-              </a:lnSpc>
-            </a:pPr>
-            <a:r>
-              <a:rPr sz="1400" b="0">
-                <a:solidFill>
-                  <a:srgbClr val="FFFFFF"/>
-                </a:solidFill>
-              </a:rPr>
-              <a:t/>
-            </a:r>
-          </a:p>
-          <a:p>
-            <a:pPr algn="l">
-              <a:lnSpc>
-                <a:spcPts val="1800"/>
-              </a:lnSpc>
-            </a:pPr>
-            <a:r>
-              <a:rPr sz="1400" b="0">
-                <a:solidFill>
-                  <a:srgbClr val="8B949E"/>
-                </a:solidFill>
-              </a:rPr>
-              <a:t>Across a 12-turn run costing $0.10 without caching:</a:t>
-            </a:r>
-          </a:p>
-          <a:p>
-            <a:pPr algn="l">
-              <a:lnSpc>
-                <a:spcPts val="1800"/>
-              </a:lnSpc>
-            </a:pPr>
-            <a:r>
-              <a:rPr sz="1400" b="0">
-                <a:solidFill>
-                  <a:srgbClr val="39D353"/>
-                </a:solidFill>
-              </a:rPr>
-              <a:t>  Cached portion 80%, discount 90%  →  savings ≈ $0.072  →  total ≈ $0.028</a:t>
+                  <a:srgbClr val="FFFFFF"/>
+                </a:solidFill>
+              </a:rPr>
+              <a:t>  • WORKSHOP_MODEL overrides the model (default deepseek-r1:8b).</a:t>
             </a:r>
           </a:p>
         </p:txBody>
@@ -37047,7 +36969,7 @@
                   <a:srgbClr val="FFFFFF"/>
                 </a:solidFill>
               </a:rPr>
-              <a:t>The agent uses prompt caching by setting cache_control: { type: 'ephemeral' }. In a 12-turn run costing $0.10 without caching, what saving would you expect if the cached portion is 80% and the cache read discount is 90%?</a:t>
+              <a:t>DeepSeek-R1 has no native tool-calling, so the agent uses a prompt-based JSON action protocol — one { tool, input } object per turn. What are the failure modes of parsing model output this way, and how would you make the loop robust to them?</a:t>
             </a:r>
           </a:p>
         </p:txBody>
@@ -37861,7 +37783,7 @@
                   <a:srgbClr val="8B949E"/>
                 </a:solidFill>
               </a:rPr>
-              <a:t>ANTHROPIC_API_KEY=sk-... npx ts-node examples/ch5-custom-agent/agent.ts
+              <a:t>npx ts-node examples/ch5-custom-agent/agent.ts
 Watch the per-step log. How many snapshot() calls in the full e-commerce run?</a:t>
             </a:r>
           </a:p>
@@ -38265,7 +38187,7 @@
                   <a:srgbClr val="FFFFFF"/>
                 </a:solidFill>
               </a:rPr>
-              <a:t>Measure cache hit rate</a:t>
+              <a:t>Measure warm-up time</a:t>
             </a:r>
           </a:p>
         </p:txBody>
@@ -38299,8 +38221,8 @@
                   <a:srgbClr val="8B949E"/>
                 </a:solidFill>
               </a:rPr>
-              <a:t>Log response.usage.cache_read_input_tokens after each turn.
-Confirm it's 0 on turn 1 and &gt; 0 on all subsequent turns.</a:t>
+              <a:t>Log the wall-clock duration of each chat() call.
+Confirm turn 1 is slowest (model load) and later turns are faster.</a:t>
             </a:r>
           </a:p>
         </p:txBody>
@@ -44408,7 +44330,7 @@
                   <a:srgbClr val="39D353"/>
                 </a:solidFill>
               </a:rPr>
-              <a:t>ANTHROPIC_API_KEY=sk-ant-... node -e "require('@anthropic-ai/sdk')"</a:t>
+              <a:t>ollama run deepseek-r1:8b 'hello'</a:t>
             </a:r>
           </a:p>
           <a:p>
@@ -44423,7 +44345,7 @@
                   <a:srgbClr val="8B949E"/>
                 </a:solidFill>
               </a:rPr>
-              <a:t>  → no error = SDK wired correctly</a:t>
+              <a:t>  → a response = local model wired correctly</a:t>
             </a:r>
           </a:p>
           <a:p>
@@ -49329,7 +49251,7 @@
                 </a:solidFill>
               </a:rPr>
               <a:t>Open .github/workflows/agentic-tests.yml. Trace: trigger → type-check → matrix.
-Find where ANTHROPIC_API_KEY is injected and why it's gated to main.</a:t>
+Find where the agent connects to Ollama and why the agentic matrix is gated to main (runtime cost).</a:t>
             </a:r>
           </a:p>
         </p:txBody>
@@ -49655,7 +49577,7 @@
                   <a:srgbClr val="FFFFFF"/>
                 </a:solidFill>
               </a:rPr>
-              <a:t>Claude Sonnet 4.6  ·  Anthropic SDK  ·  Prompt caching  ·  Tool use</a:t>
+              <a:t>DeepSeek-R1  ·  Ollama  ·  Local inference  ·  JSON actions</a:t>
             </a:r>
           </a:p>
         </p:txBody>
@@ -52489,7 +52411,7 @@
                   <a:srgbClr val="D2A8FF"/>
                 </a:solidFill>
               </a:rPr>
-              <a:t>Anthropic SDK</a:t>
+              <a:t>Ollama</a:t>
             </a:r>
           </a:p>
           <a:p>
@@ -52504,7 +52426,52 @@
                   <a:srgbClr val="FFFFFF"/>
                 </a:solidFill>
               </a:rPr>
-              <a:t>  docs.anthropic.com  ·  npmjs.com/package/@anthropic-ai/sdk</a:t>
+              <a:t>  ollama.com  ·  npmjs.com/package/ollama</a:t>
+            </a:r>
+          </a:p>
+          <a:p>
+            <a:pPr algn="l">
+              <a:lnSpc>
+                <a:spcPts val="1800"/>
+              </a:lnSpc>
+            </a:pPr>
+            <a:r>
+              <a:rPr sz="1400" b="0">
+                <a:solidFill>
+                  <a:srgbClr val="FFFFFF"/>
+                </a:solidFill>
+              </a:rPr>
+              <a:t/>
+            </a:r>
+          </a:p>
+          <a:p>
+            <a:pPr algn="l">
+              <a:lnSpc>
+                <a:spcPts val="1800"/>
+              </a:lnSpc>
+            </a:pPr>
+            <a:r>
+              <a:rPr sz="1400" b="0">
+                <a:solidFill>
+                  <a:srgbClr val="FFA657"/>
+                </a:solidFill>
+              </a:rPr>
+              <a:t>DeepSeek-R1</a:t>
+            </a:r>
+          </a:p>
+          <a:p>
+            <a:pPr algn="l">
+              <a:lnSpc>
+                <a:spcPts val="1800"/>
+              </a:lnSpc>
+            </a:pPr>
+            <a:r>
+              <a:rPr sz="1400" b="0">
+                <a:solidFill>
+                  <a:srgbClr val="FFFFFF"/>
+                </a:solidFill>
+              </a:rPr>
+              <a:t>  ollama.com/library/deepseek-r1</a:t>
             </a:r>
           </a:p>
           <a:p>
@@ -52933,7 +52900,7 @@
                   <a:srgbClr val="8B949E"/>
                 </a:solidFill>
               </a:rPr>
-              <a:t>playwright.dev  ·  docs.anthropic.com  ·  modelcontextprotocol.io</a:t>
+              <a:t>playwright.dev  ·  ollama.com  ·  modelcontextprotocol.io</a:t>
             </a:r>
           </a:p>
           <a:p>

</xml_diff>